<commit_message>
docs | update Overview of Go Language
</commit_message>
<xml_diff>
--- a/docs/Overview of Go Language.pptx
+++ b/docs/Overview of Go Language.pptx
@@ -637,11 +637,34 @@
           <a:bodyPr/>
           <a:lstStyle/>
           <a:p>
-            <a:endParaRPr lang="en-US">
-              <a:solidFill>
-                <a:schemeClr val="tx1"/>
-              </a:solidFill>
-            </a:endParaRPr>
+            <a:r>
+              <a:rPr lang="en-US" dirty="0">
+                <a:solidFill>
+                  <a:schemeClr val="tx1"/>
+                </a:solidFill>
+              </a:rPr>
+              <a:t>A goroutine is launched with a single keyword — go</a:t>
+            </a:r>
+          </a:p>
+          <a:p>
+            <a:r>
+              <a:rPr lang="en-US" dirty="0">
+                <a:solidFill>
+                  <a:schemeClr val="tx1"/>
+                </a:solidFill>
+              </a:rPr>
+              <a:t>Goroutines are not OS threads — Go manages thousands of them on a small thread pool</a:t>
+            </a:r>
+          </a:p>
+          <a:p>
+            <a:r>
+              <a:rPr lang="en-US" dirty="0">
+                <a:solidFill>
+                  <a:schemeClr val="tx1"/>
+                </a:solidFill>
+              </a:rPr>
+              <a:t>Channels let goroutines communicate without shared memory or locks</a:t>
+            </a:r>
           </a:p>
         </p:txBody>
       </p:sp>
@@ -1457,11 +1480,66 @@
           <a:bodyPr/>
           <a:lstStyle/>
           <a:p>
-            <a:endParaRPr lang="en-US">
-              <a:solidFill>
-                <a:schemeClr val="tx1"/>
-              </a:solidFill>
-            </a:endParaRPr>
+            <a:r>
+              <a:rPr lang="en-US" dirty="0">
+                <a:solidFill>
+                  <a:schemeClr val="tx1"/>
+                </a:solidFill>
+              </a:rPr>
+              <a:t>No parent/child hierarchy – structs satisfy interfaces implicitly</a:t>
+            </a:r>
+          </a:p>
+          <a:p>
+            <a:r>
+              <a:rPr lang="en-US" dirty="0" err="1">
+                <a:solidFill>
+                  <a:schemeClr val="tx1"/>
+                </a:solidFill>
+              </a:rPr>
+              <a:t>TitleScene</a:t>
+            </a:r>
+            <a:r>
+              <a:rPr lang="en-US" dirty="0">
+                <a:solidFill>
+                  <a:schemeClr val="tx1"/>
+                </a:solidFill>
+              </a:rPr>
+              <a:t> and </a:t>
+            </a:r>
+            <a:r>
+              <a:rPr lang="en-US" dirty="0" err="1">
+                <a:solidFill>
+                  <a:schemeClr val="tx1"/>
+                </a:solidFill>
+              </a:rPr>
+              <a:t>GameScene</a:t>
+            </a:r>
+            <a:r>
+              <a:rPr lang="en-US" dirty="0">
+                <a:solidFill>
+                  <a:schemeClr val="tx1"/>
+                </a:solidFill>
+              </a:rPr>
+              <a:t> have no knowledge of each other</a:t>
+            </a:r>
+          </a:p>
+          <a:p>
+            <a:r>
+              <a:rPr lang="en-US" dirty="0" err="1">
+                <a:solidFill>
+                  <a:schemeClr val="tx1"/>
+                </a:solidFill>
+              </a:rPr>
+              <a:t>SceneManager</a:t>
+            </a:r>
+            <a:r>
+              <a:rPr lang="en-US" dirty="0">
+                <a:solidFill>
+                  <a:schemeClr val="tx1"/>
+                </a:solidFill>
+              </a:rPr>
+              <a:t> holds either one via the Scene interface – no casting, no coordination</a:t>
+            </a:r>
           </a:p>
         </p:txBody>
       </p:sp>
@@ -1569,11 +1647,34 @@
           <a:bodyPr/>
           <a:lstStyle/>
           <a:p>
-            <a:endParaRPr lang="en-US">
-              <a:solidFill>
-                <a:schemeClr val="tx1"/>
-              </a:solidFill>
-            </a:endParaRPr>
+            <a:r>
+              <a:rPr lang="en-US" dirty="0">
+                <a:solidFill>
+                  <a:schemeClr val="tx1"/>
+                </a:solidFill>
+              </a:rPr>
+              <a:t>Errors are return values – you can’t ignore them without making a deliberate choice</a:t>
+            </a:r>
+          </a:p>
+          <a:p>
+            <a:r>
+              <a:rPr lang="en-US" dirty="0">
+                <a:solidFill>
+                  <a:schemeClr val="tx1"/>
+                </a:solidFill>
+              </a:rPr>
+              <a:t>The call chain is explicit</a:t>
+            </a:r>
+          </a:p>
+          <a:p>
+            <a:r>
+              <a:rPr lang="en-US" dirty="0">
+                <a:solidFill>
+                  <a:schemeClr val="tx1"/>
+                </a:solidFill>
+              </a:rPr>
+              <a:t>No hidden control flow – errors travel the same path as any other value</a:t>
+            </a:r>
           </a:p>
         </p:txBody>
       </p:sp>
@@ -1681,11 +1782,66 @@
           <a:bodyPr/>
           <a:lstStyle/>
           <a:p>
-            <a:endParaRPr lang="en-US">
-              <a:solidFill>
-                <a:schemeClr val="tx1"/>
-              </a:solidFill>
-            </a:endParaRPr>
+            <a:r>
+              <a:rPr lang="en-US" dirty="0">
+                <a:solidFill>
+                  <a:schemeClr val="tx1"/>
+                </a:solidFill>
+              </a:rPr>
+              <a:t>No configuration file — </a:t>
+            </a:r>
+            <a:r>
+              <a:rPr lang="en-US" dirty="0" err="1">
+                <a:solidFill>
+                  <a:schemeClr val="tx1"/>
+                </a:solidFill>
+              </a:rPr>
+              <a:t>gofmt</a:t>
+            </a:r>
+            <a:r>
+              <a:rPr lang="en-US" dirty="0">
+                <a:solidFill>
+                  <a:schemeClr val="tx1"/>
+                </a:solidFill>
+              </a:rPr>
+              <a:t> has no options by design</a:t>
+            </a:r>
+          </a:p>
+          <a:p>
+            <a:r>
+              <a:rPr lang="en-US" dirty="0">
+                <a:solidFill>
+                  <a:schemeClr val="tx1"/>
+                </a:solidFill>
+              </a:rPr>
+              <a:t>Code reviews focus on logic, not style</a:t>
+            </a:r>
+          </a:p>
+          <a:p>
+            <a:r>
+              <a:rPr lang="en-US" dirty="0">
+                <a:solidFill>
+                  <a:schemeClr val="tx1"/>
+                </a:solidFill>
+              </a:rPr>
+              <a:t>The Asteroids codebase runs </a:t>
+            </a:r>
+            <a:r>
+              <a:rPr lang="en-US" dirty="0" err="1">
+                <a:solidFill>
+                  <a:schemeClr val="tx1"/>
+                </a:solidFill>
+              </a:rPr>
+              <a:t>gofmt</a:t>
+            </a:r>
+            <a:r>
+              <a:rPr lang="en-US" dirty="0">
+                <a:solidFill>
+                  <a:schemeClr val="tx1"/>
+                </a:solidFill>
+              </a:rPr>
+              <a:t> — you didn't choose that, it just is</a:t>
+            </a:r>
           </a:p>
         </p:txBody>
       </p:sp>
@@ -5565,7 +5721,7 @@
         <p:spPr>
           <a:xfrm>
             <a:off x="1279019" y="2526526"/>
-            <a:ext cx="9633962" cy="3554457"/>
+            <a:ext cx="9633962" cy="642511"/>
           </a:xfrm>
         </p:spPr>
         <p:txBody>
@@ -5574,11 +5730,301 @@
           </a:bodyPr>
           <a:lstStyle/>
           <a:p>
-            <a:endParaRPr lang="en-US" dirty="0">
-              <a:solidFill>
-                <a:schemeClr val="tx1"/>
-              </a:solidFill>
-            </a:endParaRPr>
+            <a:pPr marL="0" indent="0">
+              <a:buNone/>
+            </a:pPr>
+            <a:r>
+              <a:rPr lang="en-US" dirty="0">
+                <a:solidFill>
+                  <a:schemeClr val="tx1"/>
+                </a:solidFill>
+              </a:rPr>
+              <a:t>Go replaces OS thread management with goroutines — lightweight, cheap, and built into the language.</a:t>
+            </a:r>
+          </a:p>
+        </p:txBody>
+      </p:sp>
+      <p:sp>
+        <p:nvSpPr>
+          <p:cNvPr id="4" name="Content Placeholder 2">
+            <a:extLst>
+              <a:ext uri="{FF2B5EF4-FFF2-40B4-BE49-F238E27FC236}">
+                <a16:creationId xmlns:a16="http://schemas.microsoft.com/office/drawing/2014/main" id="{AF4C27AD-AE5C-8C05-2703-B51D00F3D132}"/>
+              </a:ext>
+            </a:extLst>
+          </p:cNvPr>
+          <p:cNvSpPr txBox="1">
+            <a:spLocks/>
+          </p:cNvSpPr>
+          <p:nvPr/>
+        </p:nvSpPr>
+        <p:spPr>
+          <a:xfrm>
+            <a:off x="1279019" y="5674277"/>
+            <a:ext cx="9633962" cy="415626"/>
+          </a:xfrm>
+          <a:prstGeom prst="rect">
+            <a:avLst/>
+          </a:prstGeom>
+        </p:spPr>
+        <p:txBody>
+          <a:bodyPr vert="horz" lIns="91440" tIns="45720" rIns="91440" bIns="45720" rtlCol="0" anchor="t">
+            <a:normAutofit/>
+          </a:bodyPr>
+          <a:lstStyle>
+            <a:lvl1pPr marL="182880" indent="-182880" algn="l" defTabSz="914400" rtl="0" eaLnBrk="1" latinLnBrk="0" hangingPunct="1">
+              <a:lnSpc>
+                <a:spcPct val="90000"/>
+              </a:lnSpc>
+              <a:spcBef>
+                <a:spcPts val="1200"/>
+              </a:spcBef>
+              <a:buClr>
+                <a:schemeClr val="accent1"/>
+              </a:buClr>
+              <a:buFont typeface="Wingdings 2" pitchFamily="18" charset="2"/>
+              <a:buChar char=""/>
+              <a:defRPr sz="2000" kern="1200">
+                <a:solidFill>
+                  <a:schemeClr val="tx1">
+                    <a:lumMod val="65000"/>
+                    <a:lumOff val="35000"/>
+                  </a:schemeClr>
+                </a:solidFill>
+                <a:latin typeface="+mn-lt"/>
+                <a:ea typeface="+mn-ea"/>
+                <a:cs typeface="+mn-cs"/>
+              </a:defRPr>
+            </a:lvl1pPr>
+            <a:lvl2pPr marL="685800" indent="-182880" algn="l" defTabSz="914400" rtl="0" eaLnBrk="1" latinLnBrk="0" hangingPunct="1">
+              <a:lnSpc>
+                <a:spcPct val="90000"/>
+              </a:lnSpc>
+              <a:spcBef>
+                <a:spcPts val="250"/>
+              </a:spcBef>
+              <a:spcAft>
+                <a:spcPts val="250"/>
+              </a:spcAft>
+              <a:buClr>
+                <a:schemeClr val="accent1"/>
+              </a:buClr>
+              <a:buFont typeface="Wingdings 2" pitchFamily="18" charset="2"/>
+              <a:buChar char=""/>
+              <a:defRPr sz="1800" kern="1200">
+                <a:solidFill>
+                  <a:schemeClr val="tx1">
+                    <a:lumMod val="65000"/>
+                    <a:lumOff val="35000"/>
+                  </a:schemeClr>
+                </a:solidFill>
+                <a:latin typeface="+mn-lt"/>
+                <a:ea typeface="+mn-ea"/>
+                <a:cs typeface="+mn-cs"/>
+              </a:defRPr>
+            </a:lvl2pPr>
+            <a:lvl3pPr marL="1143000" indent="-182880" algn="l" defTabSz="914400" rtl="0" eaLnBrk="1" latinLnBrk="0" hangingPunct="1">
+              <a:lnSpc>
+                <a:spcPct val="90000"/>
+              </a:lnSpc>
+              <a:spcBef>
+                <a:spcPts val="250"/>
+              </a:spcBef>
+              <a:spcAft>
+                <a:spcPts val="250"/>
+              </a:spcAft>
+              <a:buClr>
+                <a:schemeClr val="accent1"/>
+              </a:buClr>
+              <a:buFont typeface="Wingdings 2" pitchFamily="18" charset="2"/>
+              <a:buChar char=""/>
+              <a:defRPr sz="1600" kern="1200">
+                <a:solidFill>
+                  <a:schemeClr val="tx1">
+                    <a:lumMod val="65000"/>
+                    <a:lumOff val="35000"/>
+                  </a:schemeClr>
+                </a:solidFill>
+                <a:latin typeface="+mn-lt"/>
+                <a:ea typeface="+mn-ea"/>
+                <a:cs typeface="+mn-cs"/>
+              </a:defRPr>
+            </a:lvl3pPr>
+            <a:lvl4pPr marL="1600200" indent="-182880" algn="l" defTabSz="914400" rtl="0" eaLnBrk="1" latinLnBrk="0" hangingPunct="1">
+              <a:lnSpc>
+                <a:spcPct val="90000"/>
+              </a:lnSpc>
+              <a:spcBef>
+                <a:spcPts val="250"/>
+              </a:spcBef>
+              <a:spcAft>
+                <a:spcPts val="250"/>
+              </a:spcAft>
+              <a:buClr>
+                <a:schemeClr val="accent1"/>
+              </a:buClr>
+              <a:buFont typeface="Wingdings 2" pitchFamily="18" charset="2"/>
+              <a:buChar char=""/>
+              <a:defRPr sz="1400" kern="1200">
+                <a:solidFill>
+                  <a:schemeClr val="tx1">
+                    <a:lumMod val="65000"/>
+                    <a:lumOff val="35000"/>
+                  </a:schemeClr>
+                </a:solidFill>
+                <a:latin typeface="+mn-lt"/>
+                <a:ea typeface="+mn-ea"/>
+                <a:cs typeface="+mn-cs"/>
+              </a:defRPr>
+            </a:lvl4pPr>
+            <a:lvl5pPr marL="2057400" indent="-182880" algn="l" defTabSz="914400" rtl="0" eaLnBrk="1" latinLnBrk="0" hangingPunct="1">
+              <a:lnSpc>
+                <a:spcPct val="90000"/>
+              </a:lnSpc>
+              <a:spcBef>
+                <a:spcPts val="250"/>
+              </a:spcBef>
+              <a:spcAft>
+                <a:spcPts val="250"/>
+              </a:spcAft>
+              <a:buClr>
+                <a:schemeClr val="accent1"/>
+              </a:buClr>
+              <a:buFont typeface="Wingdings 2" pitchFamily="18" charset="2"/>
+              <a:buChar char=""/>
+              <a:defRPr sz="1400" kern="1200">
+                <a:solidFill>
+                  <a:schemeClr val="tx1">
+                    <a:lumMod val="65000"/>
+                    <a:lumOff val="35000"/>
+                  </a:schemeClr>
+                </a:solidFill>
+                <a:latin typeface="+mn-lt"/>
+                <a:ea typeface="+mn-ea"/>
+                <a:cs typeface="+mn-cs"/>
+              </a:defRPr>
+            </a:lvl5pPr>
+            <a:lvl6pPr marL="2514600" indent="-228600" algn="l" defTabSz="914400" rtl="0" eaLnBrk="1" latinLnBrk="0" hangingPunct="1">
+              <a:lnSpc>
+                <a:spcPct val="90000"/>
+              </a:lnSpc>
+              <a:spcBef>
+                <a:spcPts val="250"/>
+              </a:spcBef>
+              <a:spcAft>
+                <a:spcPts val="250"/>
+              </a:spcAft>
+              <a:buClr>
+                <a:schemeClr val="accent1"/>
+              </a:buClr>
+              <a:buFont typeface="Wingdings 2" pitchFamily="18" charset="2"/>
+              <a:buChar char=""/>
+              <a:defRPr sz="1400" kern="1200">
+                <a:solidFill>
+                  <a:schemeClr val="tx1">
+                    <a:lumMod val="65000"/>
+                    <a:lumOff val="35000"/>
+                  </a:schemeClr>
+                </a:solidFill>
+                <a:latin typeface="+mn-lt"/>
+                <a:ea typeface="+mn-ea"/>
+                <a:cs typeface="+mn-cs"/>
+              </a:defRPr>
+            </a:lvl6pPr>
+            <a:lvl7pPr marL="2971800" indent="-228600" algn="l" defTabSz="914400" rtl="0" eaLnBrk="1" latinLnBrk="0" hangingPunct="1">
+              <a:lnSpc>
+                <a:spcPct val="90000"/>
+              </a:lnSpc>
+              <a:spcBef>
+                <a:spcPts val="250"/>
+              </a:spcBef>
+              <a:spcAft>
+                <a:spcPts val="250"/>
+              </a:spcAft>
+              <a:buClr>
+                <a:schemeClr val="accent1"/>
+              </a:buClr>
+              <a:buFont typeface="Wingdings 2" pitchFamily="18" charset="2"/>
+              <a:buChar char=""/>
+              <a:defRPr sz="1400" kern="1200">
+                <a:solidFill>
+                  <a:schemeClr val="tx1">
+                    <a:lumMod val="65000"/>
+                    <a:lumOff val="35000"/>
+                  </a:schemeClr>
+                </a:solidFill>
+                <a:latin typeface="+mn-lt"/>
+                <a:ea typeface="+mn-ea"/>
+                <a:cs typeface="+mn-cs"/>
+              </a:defRPr>
+            </a:lvl7pPr>
+            <a:lvl8pPr marL="3429000" indent="-228600" algn="l" defTabSz="914400" rtl="0" eaLnBrk="1" latinLnBrk="0" hangingPunct="1">
+              <a:lnSpc>
+                <a:spcPct val="90000"/>
+              </a:lnSpc>
+              <a:spcBef>
+                <a:spcPts val="250"/>
+              </a:spcBef>
+              <a:spcAft>
+                <a:spcPts val="250"/>
+              </a:spcAft>
+              <a:buClr>
+                <a:schemeClr val="accent1"/>
+              </a:buClr>
+              <a:buFont typeface="Wingdings 2" pitchFamily="18" charset="2"/>
+              <a:buChar char=""/>
+              <a:defRPr sz="1400" kern="1200">
+                <a:solidFill>
+                  <a:schemeClr val="tx1">
+                    <a:lumMod val="65000"/>
+                    <a:lumOff val="35000"/>
+                  </a:schemeClr>
+                </a:solidFill>
+                <a:latin typeface="+mn-lt"/>
+                <a:ea typeface="+mn-ea"/>
+                <a:cs typeface="+mn-cs"/>
+              </a:defRPr>
+            </a:lvl8pPr>
+            <a:lvl9pPr marL="3886200" indent="-228600" algn="l" defTabSz="914400" rtl="0" eaLnBrk="1" latinLnBrk="0" hangingPunct="1">
+              <a:lnSpc>
+                <a:spcPct val="90000"/>
+              </a:lnSpc>
+              <a:spcBef>
+                <a:spcPts val="250"/>
+              </a:spcBef>
+              <a:spcAft>
+                <a:spcPts val="250"/>
+              </a:spcAft>
+              <a:buClr>
+                <a:schemeClr val="accent1"/>
+              </a:buClr>
+              <a:buFont typeface="Wingdings 2" pitchFamily="18" charset="2"/>
+              <a:buChar char=""/>
+              <a:defRPr sz="1400" kern="1200">
+                <a:solidFill>
+                  <a:schemeClr val="tx1">
+                    <a:lumMod val="65000"/>
+                    <a:lumOff val="35000"/>
+                  </a:schemeClr>
+                </a:solidFill>
+                <a:latin typeface="+mn-lt"/>
+                <a:ea typeface="+mn-ea"/>
+                <a:cs typeface="+mn-cs"/>
+              </a:defRPr>
+            </a:lvl9pPr>
+          </a:lstStyle>
+          <a:p>
+            <a:pPr marL="0" indent="0">
+              <a:buNone/>
+            </a:pPr>
+            <a:r>
+              <a:rPr lang="en-US" dirty="0">
+                <a:solidFill>
+                  <a:schemeClr val="tx1"/>
+                </a:solidFill>
+              </a:rPr>
+              <a:t>Built-in concurrency — not bolted on, not a library, part of the language from day one.</a:t>
+            </a:r>
           </a:p>
         </p:txBody>
       </p:sp>
@@ -7953,14 +8399,14 @@
               <a:buNone/>
             </a:pPr>
             <a:r>
-              <a:rPr lang="en-US" b="1">
+              <a:rPr lang="en-US" b="1" dirty="0">
                 <a:solidFill>
                   <a:srgbClr val="08A8D2"/>
                 </a:solidFill>
               </a:rPr>
               <a:t>Problems</a:t>
             </a:r>
-            <a:endParaRPr lang="en-US" b="1">
+            <a:endParaRPr lang="en-US" b="1" dirty="0">
               <a:solidFill>
                 <a:schemeClr val="tx1"/>
               </a:solidFill>
@@ -7968,17 +8414,17 @@
           </a:p>
           <a:p>
             <a:r>
-              <a:rPr lang="en-US" sz="1600">
+              <a:rPr lang="en-US" sz="1600" dirty="0">
                 <a:solidFill>
                   <a:schemeClr val="tx1"/>
                 </a:solidFill>
               </a:rPr>
-              <a:t>Slow Builds</a:t>
-            </a:r>
-          </a:p>
-          <a:p>
-            <a:r>
-              <a:rPr lang="en-US" sz="1600">
+              <a:t>Slow Builds (C++)</a:t>
+            </a:r>
+          </a:p>
+          <a:p>
+            <a:r>
+              <a:rPr lang="en-US" sz="1600" dirty="0">
                 <a:solidFill>
                   <a:schemeClr val="tx1"/>
                 </a:solidFill>
@@ -7988,7 +8434,7 @@
           </a:p>
           <a:p>
             <a:r>
-              <a:rPr lang="en-US" sz="1600">
+              <a:rPr lang="en-US" sz="1600" dirty="0">
                 <a:solidFill>
                   <a:schemeClr val="tx1"/>
                 </a:solidFill>
@@ -7998,7 +8444,7 @@
           </a:p>
           <a:p>
             <a:r>
-              <a:rPr lang="en-US" sz="1600">
+              <a:rPr lang="en-US" sz="1600" dirty="0">
                 <a:solidFill>
                   <a:schemeClr val="tx1"/>
                 </a:solidFill>
@@ -8008,7 +8454,7 @@
           </a:p>
           <a:p>
             <a:r>
-              <a:rPr lang="en-US" sz="1600">
+              <a:rPr lang="en-US" sz="1600" dirty="0">
                 <a:solidFill>
                   <a:schemeClr val="tx1"/>
                 </a:solidFill>
@@ -8017,7 +8463,7 @@
             </a:r>
           </a:p>
           <a:p>
-            <a:endParaRPr lang="en-US">
+            <a:endParaRPr lang="en-US" dirty="0">
               <a:solidFill>
                 <a:schemeClr val="tx1"/>
               </a:solidFill>
@@ -11062,7 +11508,7 @@
         <p:spPr>
           <a:xfrm>
             <a:off x="1279019" y="2526526"/>
-            <a:ext cx="9633962" cy="3554457"/>
+            <a:ext cx="9633962" cy="642511"/>
           </a:xfrm>
         </p:spPr>
         <p:txBody>
@@ -11071,11 +11517,378 @@
           </a:bodyPr>
           <a:lstStyle/>
           <a:p>
-            <a:endParaRPr lang="en-US" dirty="0">
-              <a:solidFill>
-                <a:schemeClr val="tx1"/>
-              </a:solidFill>
-            </a:endParaRPr>
+            <a:pPr marL="0" indent="0">
+              <a:buNone/>
+            </a:pPr>
+            <a:r>
+              <a:rPr lang="en-US" dirty="0">
+                <a:solidFill>
+                  <a:schemeClr val="tx1"/>
+                </a:solidFill>
+              </a:rPr>
+              <a:t>Go has no </a:t>
+            </a:r>
+            <a:r>
+              <a:rPr lang="en-US" b="1" i="1" dirty="0">
+                <a:solidFill>
+                  <a:schemeClr val="tx1"/>
+                </a:solidFill>
+              </a:rPr>
+              <a:t>try/catch</a:t>
+            </a:r>
+            <a:r>
+              <a:rPr lang="en-US" dirty="0">
+                <a:solidFill>
+                  <a:schemeClr val="tx1"/>
+                </a:solidFill>
+              </a:rPr>
+              <a:t>. Errors are just values – returned, checked, and handled explicitly.</a:t>
+            </a:r>
+          </a:p>
+        </p:txBody>
+      </p:sp>
+      <p:pic>
+        <p:nvPicPr>
+          <p:cNvPr id="4" name="Picture 3">
+            <a:extLst>
+              <a:ext uri="{FF2B5EF4-FFF2-40B4-BE49-F238E27FC236}">
+                <a16:creationId xmlns:a16="http://schemas.microsoft.com/office/drawing/2014/main" id="{61579C6C-DDD5-9734-3A00-B19B483E5082}"/>
+              </a:ext>
+            </a:extLst>
+          </p:cNvPr>
+          <p:cNvPicPr>
+            <a:picLocks noChangeAspect="1"/>
+          </p:cNvPicPr>
+          <p:nvPr/>
+        </p:nvPicPr>
+        <p:blipFill>
+          <a:blip r:embed="rId3"/>
+          <a:stretch>
+            <a:fillRect/>
+          </a:stretch>
+        </p:blipFill>
+        <p:spPr>
+          <a:xfrm>
+            <a:off x="1279019" y="3664620"/>
+            <a:ext cx="4429539" cy="964850"/>
+          </a:xfrm>
+          <a:prstGeom prst="rect">
+            <a:avLst/>
+          </a:prstGeom>
+        </p:spPr>
+      </p:pic>
+      <p:pic>
+        <p:nvPicPr>
+          <p:cNvPr id="5" name="Picture 4">
+            <a:extLst>
+              <a:ext uri="{FF2B5EF4-FFF2-40B4-BE49-F238E27FC236}">
+                <a16:creationId xmlns:a16="http://schemas.microsoft.com/office/drawing/2014/main" id="{AD61A486-D2D1-E602-7F28-96F3DC67A9ED}"/>
+              </a:ext>
+            </a:extLst>
+          </p:cNvPr>
+          <p:cNvPicPr>
+            <a:picLocks noChangeAspect="1"/>
+          </p:cNvPicPr>
+          <p:nvPr/>
+        </p:nvPicPr>
+        <p:blipFill>
+          <a:blip r:embed="rId4"/>
+          <a:stretch>
+            <a:fillRect/>
+          </a:stretch>
+        </p:blipFill>
+        <p:spPr>
+          <a:xfrm>
+            <a:off x="6092498" y="3688964"/>
+            <a:ext cx="4978878" cy="950258"/>
+          </a:xfrm>
+          <a:prstGeom prst="rect">
+            <a:avLst/>
+          </a:prstGeom>
+        </p:spPr>
+      </p:pic>
+      <p:sp>
+        <p:nvSpPr>
+          <p:cNvPr id="6" name="Content Placeholder 2">
+            <a:extLst>
+              <a:ext uri="{FF2B5EF4-FFF2-40B4-BE49-F238E27FC236}">
+                <a16:creationId xmlns:a16="http://schemas.microsoft.com/office/drawing/2014/main" id="{3809E808-0487-9572-9CE5-C245CC7BF37C}"/>
+              </a:ext>
+            </a:extLst>
+          </p:cNvPr>
+          <p:cNvSpPr txBox="1">
+            <a:spLocks/>
+          </p:cNvSpPr>
+          <p:nvPr/>
+        </p:nvSpPr>
+        <p:spPr>
+          <a:xfrm>
+            <a:off x="1279019" y="5563833"/>
+            <a:ext cx="9633962" cy="642511"/>
+          </a:xfrm>
+          <a:prstGeom prst="rect">
+            <a:avLst/>
+          </a:prstGeom>
+        </p:spPr>
+        <p:txBody>
+          <a:bodyPr vert="horz" lIns="91440" tIns="45720" rIns="91440" bIns="45720" rtlCol="0" anchor="t">
+            <a:normAutofit/>
+          </a:bodyPr>
+          <a:lstStyle>
+            <a:lvl1pPr marL="182880" indent="-182880" algn="l" defTabSz="914400" rtl="0" eaLnBrk="1" latinLnBrk="0" hangingPunct="1">
+              <a:lnSpc>
+                <a:spcPct val="90000"/>
+              </a:lnSpc>
+              <a:spcBef>
+                <a:spcPts val="1200"/>
+              </a:spcBef>
+              <a:buClr>
+                <a:schemeClr val="accent1"/>
+              </a:buClr>
+              <a:buFont typeface="Wingdings 2" pitchFamily="18" charset="2"/>
+              <a:buChar char=""/>
+              <a:defRPr sz="2000" kern="1200">
+                <a:solidFill>
+                  <a:schemeClr val="tx1">
+                    <a:lumMod val="65000"/>
+                    <a:lumOff val="35000"/>
+                  </a:schemeClr>
+                </a:solidFill>
+                <a:latin typeface="+mn-lt"/>
+                <a:ea typeface="+mn-ea"/>
+                <a:cs typeface="+mn-cs"/>
+              </a:defRPr>
+            </a:lvl1pPr>
+            <a:lvl2pPr marL="685800" indent="-182880" algn="l" defTabSz="914400" rtl="0" eaLnBrk="1" latinLnBrk="0" hangingPunct="1">
+              <a:lnSpc>
+                <a:spcPct val="90000"/>
+              </a:lnSpc>
+              <a:spcBef>
+                <a:spcPts val="250"/>
+              </a:spcBef>
+              <a:spcAft>
+                <a:spcPts val="250"/>
+              </a:spcAft>
+              <a:buClr>
+                <a:schemeClr val="accent1"/>
+              </a:buClr>
+              <a:buFont typeface="Wingdings 2" pitchFamily="18" charset="2"/>
+              <a:buChar char=""/>
+              <a:defRPr sz="1800" kern="1200">
+                <a:solidFill>
+                  <a:schemeClr val="tx1">
+                    <a:lumMod val="65000"/>
+                    <a:lumOff val="35000"/>
+                  </a:schemeClr>
+                </a:solidFill>
+                <a:latin typeface="+mn-lt"/>
+                <a:ea typeface="+mn-ea"/>
+                <a:cs typeface="+mn-cs"/>
+              </a:defRPr>
+            </a:lvl2pPr>
+            <a:lvl3pPr marL="1143000" indent="-182880" algn="l" defTabSz="914400" rtl="0" eaLnBrk="1" latinLnBrk="0" hangingPunct="1">
+              <a:lnSpc>
+                <a:spcPct val="90000"/>
+              </a:lnSpc>
+              <a:spcBef>
+                <a:spcPts val="250"/>
+              </a:spcBef>
+              <a:spcAft>
+                <a:spcPts val="250"/>
+              </a:spcAft>
+              <a:buClr>
+                <a:schemeClr val="accent1"/>
+              </a:buClr>
+              <a:buFont typeface="Wingdings 2" pitchFamily="18" charset="2"/>
+              <a:buChar char=""/>
+              <a:defRPr sz="1600" kern="1200">
+                <a:solidFill>
+                  <a:schemeClr val="tx1">
+                    <a:lumMod val="65000"/>
+                    <a:lumOff val="35000"/>
+                  </a:schemeClr>
+                </a:solidFill>
+                <a:latin typeface="+mn-lt"/>
+                <a:ea typeface="+mn-ea"/>
+                <a:cs typeface="+mn-cs"/>
+              </a:defRPr>
+            </a:lvl3pPr>
+            <a:lvl4pPr marL="1600200" indent="-182880" algn="l" defTabSz="914400" rtl="0" eaLnBrk="1" latinLnBrk="0" hangingPunct="1">
+              <a:lnSpc>
+                <a:spcPct val="90000"/>
+              </a:lnSpc>
+              <a:spcBef>
+                <a:spcPts val="250"/>
+              </a:spcBef>
+              <a:spcAft>
+                <a:spcPts val="250"/>
+              </a:spcAft>
+              <a:buClr>
+                <a:schemeClr val="accent1"/>
+              </a:buClr>
+              <a:buFont typeface="Wingdings 2" pitchFamily="18" charset="2"/>
+              <a:buChar char=""/>
+              <a:defRPr sz="1400" kern="1200">
+                <a:solidFill>
+                  <a:schemeClr val="tx1">
+                    <a:lumMod val="65000"/>
+                    <a:lumOff val="35000"/>
+                  </a:schemeClr>
+                </a:solidFill>
+                <a:latin typeface="+mn-lt"/>
+                <a:ea typeface="+mn-ea"/>
+                <a:cs typeface="+mn-cs"/>
+              </a:defRPr>
+            </a:lvl4pPr>
+            <a:lvl5pPr marL="2057400" indent="-182880" algn="l" defTabSz="914400" rtl="0" eaLnBrk="1" latinLnBrk="0" hangingPunct="1">
+              <a:lnSpc>
+                <a:spcPct val="90000"/>
+              </a:lnSpc>
+              <a:spcBef>
+                <a:spcPts val="250"/>
+              </a:spcBef>
+              <a:spcAft>
+                <a:spcPts val="250"/>
+              </a:spcAft>
+              <a:buClr>
+                <a:schemeClr val="accent1"/>
+              </a:buClr>
+              <a:buFont typeface="Wingdings 2" pitchFamily="18" charset="2"/>
+              <a:buChar char=""/>
+              <a:defRPr sz="1400" kern="1200">
+                <a:solidFill>
+                  <a:schemeClr val="tx1">
+                    <a:lumMod val="65000"/>
+                    <a:lumOff val="35000"/>
+                  </a:schemeClr>
+                </a:solidFill>
+                <a:latin typeface="+mn-lt"/>
+                <a:ea typeface="+mn-ea"/>
+                <a:cs typeface="+mn-cs"/>
+              </a:defRPr>
+            </a:lvl5pPr>
+            <a:lvl6pPr marL="2514600" indent="-228600" algn="l" defTabSz="914400" rtl="0" eaLnBrk="1" latinLnBrk="0" hangingPunct="1">
+              <a:lnSpc>
+                <a:spcPct val="90000"/>
+              </a:lnSpc>
+              <a:spcBef>
+                <a:spcPts val="250"/>
+              </a:spcBef>
+              <a:spcAft>
+                <a:spcPts val="250"/>
+              </a:spcAft>
+              <a:buClr>
+                <a:schemeClr val="accent1"/>
+              </a:buClr>
+              <a:buFont typeface="Wingdings 2" pitchFamily="18" charset="2"/>
+              <a:buChar char=""/>
+              <a:defRPr sz="1400" kern="1200">
+                <a:solidFill>
+                  <a:schemeClr val="tx1">
+                    <a:lumMod val="65000"/>
+                    <a:lumOff val="35000"/>
+                  </a:schemeClr>
+                </a:solidFill>
+                <a:latin typeface="+mn-lt"/>
+                <a:ea typeface="+mn-ea"/>
+                <a:cs typeface="+mn-cs"/>
+              </a:defRPr>
+            </a:lvl6pPr>
+            <a:lvl7pPr marL="2971800" indent="-228600" algn="l" defTabSz="914400" rtl="0" eaLnBrk="1" latinLnBrk="0" hangingPunct="1">
+              <a:lnSpc>
+                <a:spcPct val="90000"/>
+              </a:lnSpc>
+              <a:spcBef>
+                <a:spcPts val="250"/>
+              </a:spcBef>
+              <a:spcAft>
+                <a:spcPts val="250"/>
+              </a:spcAft>
+              <a:buClr>
+                <a:schemeClr val="accent1"/>
+              </a:buClr>
+              <a:buFont typeface="Wingdings 2" pitchFamily="18" charset="2"/>
+              <a:buChar char=""/>
+              <a:defRPr sz="1400" kern="1200">
+                <a:solidFill>
+                  <a:schemeClr val="tx1">
+                    <a:lumMod val="65000"/>
+                    <a:lumOff val="35000"/>
+                  </a:schemeClr>
+                </a:solidFill>
+                <a:latin typeface="+mn-lt"/>
+                <a:ea typeface="+mn-ea"/>
+                <a:cs typeface="+mn-cs"/>
+              </a:defRPr>
+            </a:lvl7pPr>
+            <a:lvl8pPr marL="3429000" indent="-228600" algn="l" defTabSz="914400" rtl="0" eaLnBrk="1" latinLnBrk="0" hangingPunct="1">
+              <a:lnSpc>
+                <a:spcPct val="90000"/>
+              </a:lnSpc>
+              <a:spcBef>
+                <a:spcPts val="250"/>
+              </a:spcBef>
+              <a:spcAft>
+                <a:spcPts val="250"/>
+              </a:spcAft>
+              <a:buClr>
+                <a:schemeClr val="accent1"/>
+              </a:buClr>
+              <a:buFont typeface="Wingdings 2" pitchFamily="18" charset="2"/>
+              <a:buChar char=""/>
+              <a:defRPr sz="1400" kern="1200">
+                <a:solidFill>
+                  <a:schemeClr val="tx1">
+                    <a:lumMod val="65000"/>
+                    <a:lumOff val="35000"/>
+                  </a:schemeClr>
+                </a:solidFill>
+                <a:latin typeface="+mn-lt"/>
+                <a:ea typeface="+mn-ea"/>
+                <a:cs typeface="+mn-cs"/>
+              </a:defRPr>
+            </a:lvl8pPr>
+            <a:lvl9pPr marL="3886200" indent="-228600" algn="l" defTabSz="914400" rtl="0" eaLnBrk="1" latinLnBrk="0" hangingPunct="1">
+              <a:lnSpc>
+                <a:spcPct val="90000"/>
+              </a:lnSpc>
+              <a:spcBef>
+                <a:spcPts val="250"/>
+              </a:spcBef>
+              <a:spcAft>
+                <a:spcPts val="250"/>
+              </a:spcAft>
+              <a:buClr>
+                <a:schemeClr val="accent1"/>
+              </a:buClr>
+              <a:buFont typeface="Wingdings 2" pitchFamily="18" charset="2"/>
+              <a:buChar char=""/>
+              <a:defRPr sz="1400" kern="1200">
+                <a:solidFill>
+                  <a:schemeClr val="tx1">
+                    <a:lumMod val="65000"/>
+                    <a:lumOff val="35000"/>
+                  </a:schemeClr>
+                </a:solidFill>
+                <a:latin typeface="+mn-lt"/>
+                <a:ea typeface="+mn-ea"/>
+                <a:cs typeface="+mn-cs"/>
+              </a:defRPr>
+            </a:lvl9pPr>
+          </a:lstStyle>
+          <a:p>
+            <a:pPr marL="0" indent="0">
+              <a:buFont typeface="Wingdings 2" pitchFamily="18" charset="2"/>
+              <a:buNone/>
+            </a:pPr>
+            <a:r>
+              <a:rPr lang="en-US" dirty="0">
+                <a:solidFill>
+                  <a:schemeClr val="tx1"/>
+                </a:solidFill>
+              </a:rPr>
+              <a:t>Explicit is better – Go’s own design rule, enforced by the language itself.</a:t>
+            </a:r>
           </a:p>
         </p:txBody>
       </p:sp>
@@ -11493,7 +12306,7 @@
         <p:spPr>
           <a:xfrm>
             <a:off x="1279019" y="2526526"/>
-            <a:ext cx="9633962" cy="3554457"/>
+            <a:ext cx="9633962" cy="759599"/>
           </a:xfrm>
         </p:spPr>
         <p:txBody>
@@ -11502,11 +12315,317 @@
           </a:bodyPr>
           <a:lstStyle/>
           <a:p>
-            <a:endParaRPr lang="en-US" dirty="0">
-              <a:solidFill>
-                <a:schemeClr val="tx1"/>
-              </a:solidFill>
-            </a:endParaRPr>
+            <a:pPr marL="0" indent="0">
+              <a:buNone/>
+            </a:pPr>
+            <a:r>
+              <a:rPr lang="en-US" dirty="0">
+                <a:solidFill>
+                  <a:schemeClr val="tx1"/>
+                </a:solidFill>
+              </a:rPr>
+              <a:t>Go ships with a standardized toolchain. </a:t>
+            </a:r>
+            <a:r>
+              <a:rPr lang="en-US" b="1" i="1" dirty="0" err="1">
+                <a:solidFill>
+                  <a:schemeClr val="tx1"/>
+                </a:solidFill>
+              </a:rPr>
+              <a:t>gofmt</a:t>
+            </a:r>
+            <a:r>
+              <a:rPr lang="en-US" dirty="0">
+                <a:solidFill>
+                  <a:schemeClr val="tx1"/>
+                </a:solidFill>
+              </a:rPr>
+              <a:t> is built in — one format, no configuration, no debate.</a:t>
+            </a:r>
+          </a:p>
+        </p:txBody>
+      </p:sp>
+      <p:sp>
+        <p:nvSpPr>
+          <p:cNvPr id="4" name="Content Placeholder 2">
+            <a:extLst>
+              <a:ext uri="{FF2B5EF4-FFF2-40B4-BE49-F238E27FC236}">
+                <a16:creationId xmlns:a16="http://schemas.microsoft.com/office/drawing/2014/main" id="{2179DF22-A8C5-1382-3DED-09AD5C476923}"/>
+              </a:ext>
+            </a:extLst>
+          </p:cNvPr>
+          <p:cNvSpPr txBox="1">
+            <a:spLocks/>
+          </p:cNvSpPr>
+          <p:nvPr/>
+        </p:nvSpPr>
+        <p:spPr>
+          <a:xfrm>
+            <a:off x="1272015" y="5601123"/>
+            <a:ext cx="9633962" cy="423056"/>
+          </a:xfrm>
+          <a:prstGeom prst="rect">
+            <a:avLst/>
+          </a:prstGeom>
+        </p:spPr>
+        <p:txBody>
+          <a:bodyPr vert="horz" lIns="91440" tIns="45720" rIns="91440" bIns="45720" rtlCol="0" anchor="t">
+            <a:normAutofit/>
+          </a:bodyPr>
+          <a:lstStyle>
+            <a:lvl1pPr marL="182880" indent="-182880" algn="l" defTabSz="914400" rtl="0" eaLnBrk="1" latinLnBrk="0" hangingPunct="1">
+              <a:lnSpc>
+                <a:spcPct val="90000"/>
+              </a:lnSpc>
+              <a:spcBef>
+                <a:spcPts val="1200"/>
+              </a:spcBef>
+              <a:buClr>
+                <a:schemeClr val="accent1"/>
+              </a:buClr>
+              <a:buFont typeface="Wingdings 2" pitchFamily="18" charset="2"/>
+              <a:buChar char=""/>
+              <a:defRPr sz="2000" kern="1200">
+                <a:solidFill>
+                  <a:schemeClr val="tx1">
+                    <a:lumMod val="65000"/>
+                    <a:lumOff val="35000"/>
+                  </a:schemeClr>
+                </a:solidFill>
+                <a:latin typeface="+mn-lt"/>
+                <a:ea typeface="+mn-ea"/>
+                <a:cs typeface="+mn-cs"/>
+              </a:defRPr>
+            </a:lvl1pPr>
+            <a:lvl2pPr marL="685800" indent="-182880" algn="l" defTabSz="914400" rtl="0" eaLnBrk="1" latinLnBrk="0" hangingPunct="1">
+              <a:lnSpc>
+                <a:spcPct val="90000"/>
+              </a:lnSpc>
+              <a:spcBef>
+                <a:spcPts val="250"/>
+              </a:spcBef>
+              <a:spcAft>
+                <a:spcPts val="250"/>
+              </a:spcAft>
+              <a:buClr>
+                <a:schemeClr val="accent1"/>
+              </a:buClr>
+              <a:buFont typeface="Wingdings 2" pitchFamily="18" charset="2"/>
+              <a:buChar char=""/>
+              <a:defRPr sz="1800" kern="1200">
+                <a:solidFill>
+                  <a:schemeClr val="tx1">
+                    <a:lumMod val="65000"/>
+                    <a:lumOff val="35000"/>
+                  </a:schemeClr>
+                </a:solidFill>
+                <a:latin typeface="+mn-lt"/>
+                <a:ea typeface="+mn-ea"/>
+                <a:cs typeface="+mn-cs"/>
+              </a:defRPr>
+            </a:lvl2pPr>
+            <a:lvl3pPr marL="1143000" indent="-182880" algn="l" defTabSz="914400" rtl="0" eaLnBrk="1" latinLnBrk="0" hangingPunct="1">
+              <a:lnSpc>
+                <a:spcPct val="90000"/>
+              </a:lnSpc>
+              <a:spcBef>
+                <a:spcPts val="250"/>
+              </a:spcBef>
+              <a:spcAft>
+                <a:spcPts val="250"/>
+              </a:spcAft>
+              <a:buClr>
+                <a:schemeClr val="accent1"/>
+              </a:buClr>
+              <a:buFont typeface="Wingdings 2" pitchFamily="18" charset="2"/>
+              <a:buChar char=""/>
+              <a:defRPr sz="1600" kern="1200">
+                <a:solidFill>
+                  <a:schemeClr val="tx1">
+                    <a:lumMod val="65000"/>
+                    <a:lumOff val="35000"/>
+                  </a:schemeClr>
+                </a:solidFill>
+                <a:latin typeface="+mn-lt"/>
+                <a:ea typeface="+mn-ea"/>
+                <a:cs typeface="+mn-cs"/>
+              </a:defRPr>
+            </a:lvl3pPr>
+            <a:lvl4pPr marL="1600200" indent="-182880" algn="l" defTabSz="914400" rtl="0" eaLnBrk="1" latinLnBrk="0" hangingPunct="1">
+              <a:lnSpc>
+                <a:spcPct val="90000"/>
+              </a:lnSpc>
+              <a:spcBef>
+                <a:spcPts val="250"/>
+              </a:spcBef>
+              <a:spcAft>
+                <a:spcPts val="250"/>
+              </a:spcAft>
+              <a:buClr>
+                <a:schemeClr val="accent1"/>
+              </a:buClr>
+              <a:buFont typeface="Wingdings 2" pitchFamily="18" charset="2"/>
+              <a:buChar char=""/>
+              <a:defRPr sz="1400" kern="1200">
+                <a:solidFill>
+                  <a:schemeClr val="tx1">
+                    <a:lumMod val="65000"/>
+                    <a:lumOff val="35000"/>
+                  </a:schemeClr>
+                </a:solidFill>
+                <a:latin typeface="+mn-lt"/>
+                <a:ea typeface="+mn-ea"/>
+                <a:cs typeface="+mn-cs"/>
+              </a:defRPr>
+            </a:lvl4pPr>
+            <a:lvl5pPr marL="2057400" indent="-182880" algn="l" defTabSz="914400" rtl="0" eaLnBrk="1" latinLnBrk="0" hangingPunct="1">
+              <a:lnSpc>
+                <a:spcPct val="90000"/>
+              </a:lnSpc>
+              <a:spcBef>
+                <a:spcPts val="250"/>
+              </a:spcBef>
+              <a:spcAft>
+                <a:spcPts val="250"/>
+              </a:spcAft>
+              <a:buClr>
+                <a:schemeClr val="accent1"/>
+              </a:buClr>
+              <a:buFont typeface="Wingdings 2" pitchFamily="18" charset="2"/>
+              <a:buChar char=""/>
+              <a:defRPr sz="1400" kern="1200">
+                <a:solidFill>
+                  <a:schemeClr val="tx1">
+                    <a:lumMod val="65000"/>
+                    <a:lumOff val="35000"/>
+                  </a:schemeClr>
+                </a:solidFill>
+                <a:latin typeface="+mn-lt"/>
+                <a:ea typeface="+mn-ea"/>
+                <a:cs typeface="+mn-cs"/>
+              </a:defRPr>
+            </a:lvl5pPr>
+            <a:lvl6pPr marL="2514600" indent="-228600" algn="l" defTabSz="914400" rtl="0" eaLnBrk="1" latinLnBrk="0" hangingPunct="1">
+              <a:lnSpc>
+                <a:spcPct val="90000"/>
+              </a:lnSpc>
+              <a:spcBef>
+                <a:spcPts val="250"/>
+              </a:spcBef>
+              <a:spcAft>
+                <a:spcPts val="250"/>
+              </a:spcAft>
+              <a:buClr>
+                <a:schemeClr val="accent1"/>
+              </a:buClr>
+              <a:buFont typeface="Wingdings 2" pitchFamily="18" charset="2"/>
+              <a:buChar char=""/>
+              <a:defRPr sz="1400" kern="1200">
+                <a:solidFill>
+                  <a:schemeClr val="tx1">
+                    <a:lumMod val="65000"/>
+                    <a:lumOff val="35000"/>
+                  </a:schemeClr>
+                </a:solidFill>
+                <a:latin typeface="+mn-lt"/>
+                <a:ea typeface="+mn-ea"/>
+                <a:cs typeface="+mn-cs"/>
+              </a:defRPr>
+            </a:lvl6pPr>
+            <a:lvl7pPr marL="2971800" indent="-228600" algn="l" defTabSz="914400" rtl="0" eaLnBrk="1" latinLnBrk="0" hangingPunct="1">
+              <a:lnSpc>
+                <a:spcPct val="90000"/>
+              </a:lnSpc>
+              <a:spcBef>
+                <a:spcPts val="250"/>
+              </a:spcBef>
+              <a:spcAft>
+                <a:spcPts val="250"/>
+              </a:spcAft>
+              <a:buClr>
+                <a:schemeClr val="accent1"/>
+              </a:buClr>
+              <a:buFont typeface="Wingdings 2" pitchFamily="18" charset="2"/>
+              <a:buChar char=""/>
+              <a:defRPr sz="1400" kern="1200">
+                <a:solidFill>
+                  <a:schemeClr val="tx1">
+                    <a:lumMod val="65000"/>
+                    <a:lumOff val="35000"/>
+                  </a:schemeClr>
+                </a:solidFill>
+                <a:latin typeface="+mn-lt"/>
+                <a:ea typeface="+mn-ea"/>
+                <a:cs typeface="+mn-cs"/>
+              </a:defRPr>
+            </a:lvl7pPr>
+            <a:lvl8pPr marL="3429000" indent="-228600" algn="l" defTabSz="914400" rtl="0" eaLnBrk="1" latinLnBrk="0" hangingPunct="1">
+              <a:lnSpc>
+                <a:spcPct val="90000"/>
+              </a:lnSpc>
+              <a:spcBef>
+                <a:spcPts val="250"/>
+              </a:spcBef>
+              <a:spcAft>
+                <a:spcPts val="250"/>
+              </a:spcAft>
+              <a:buClr>
+                <a:schemeClr val="accent1"/>
+              </a:buClr>
+              <a:buFont typeface="Wingdings 2" pitchFamily="18" charset="2"/>
+              <a:buChar char=""/>
+              <a:defRPr sz="1400" kern="1200">
+                <a:solidFill>
+                  <a:schemeClr val="tx1">
+                    <a:lumMod val="65000"/>
+                    <a:lumOff val="35000"/>
+                  </a:schemeClr>
+                </a:solidFill>
+                <a:latin typeface="+mn-lt"/>
+                <a:ea typeface="+mn-ea"/>
+                <a:cs typeface="+mn-cs"/>
+              </a:defRPr>
+            </a:lvl8pPr>
+            <a:lvl9pPr marL="3886200" indent="-228600" algn="l" defTabSz="914400" rtl="0" eaLnBrk="1" latinLnBrk="0" hangingPunct="1">
+              <a:lnSpc>
+                <a:spcPct val="90000"/>
+              </a:lnSpc>
+              <a:spcBef>
+                <a:spcPts val="250"/>
+              </a:spcBef>
+              <a:spcAft>
+                <a:spcPts val="250"/>
+              </a:spcAft>
+              <a:buClr>
+                <a:schemeClr val="accent1"/>
+              </a:buClr>
+              <a:buFont typeface="Wingdings 2" pitchFamily="18" charset="2"/>
+              <a:buChar char=""/>
+              <a:defRPr sz="1400" kern="1200">
+                <a:solidFill>
+                  <a:schemeClr val="tx1">
+                    <a:lumMod val="65000"/>
+                    <a:lumOff val="35000"/>
+                  </a:schemeClr>
+                </a:solidFill>
+                <a:latin typeface="+mn-lt"/>
+                <a:ea typeface="+mn-ea"/>
+                <a:cs typeface="+mn-cs"/>
+              </a:defRPr>
+            </a:lvl9pPr>
+          </a:lstStyle>
+          <a:p>
+            <a:pPr marL="0" indent="0">
+              <a:buNone/>
+            </a:pPr>
+            <a:r>
+              <a:rPr lang="en-US" dirty="0">
+                <a:solidFill>
+                  <a:schemeClr val="tx1"/>
+                </a:solidFill>
+              </a:rPr>
+              <a:t>Optimize for teams — readability beats cleverness, and consistency beats preference</a:t>
+            </a:r>
           </a:p>
         </p:txBody>
       </p:sp>

</xml_diff>